<commit_message>
Fix layout issues in slides 2, 4, 8 — text overflow and table clipping
</commit_message>
<xml_diff>
--- a/report/Dialog_Axiata_Due_Diligence_FINAL.pptx
+++ b/report/Dialog_Axiata_Due_Diligence_FINAL.pptx
@@ -3762,18 +3762,9 @@
   <p:clrMapOvr>
     <a:masterClrMapping/>
   </p:clrMapOvr>
-  <mc:AlternateContent xmlns:mc="http://schemas.openxmlformats.org/markup-compatibility/2006">
-    <mc:Choice xmlns:p159="http://schemas.microsoft.com/office/powerpoint/2015/09/main" Requires="p159">
-      <p:transition xmlns:p14="http://schemas.microsoft.com/office/powerpoint/2010/main" spd="slow" p14:dur="2000">
-        <p159:morph option="byObject"/>
-      </p:transition>
-    </mc:Choice>
-    <mc:Fallback>
-      <p:transition spd="slow">
-        <p:fade/>
-      </p:transition>
-    </mc:Fallback>
-  </mc:AlternateContent>
+  <p:transition spd="slow">
+    <p:wipe/>
+  </p:transition>
 </p:sld>
 </file>
 
@@ -5217,18 +5208,9 @@
   <p:clrMapOvr>
     <a:masterClrMapping/>
   </p:clrMapOvr>
-  <mc:AlternateContent xmlns:mc="http://schemas.openxmlformats.org/markup-compatibility/2006">
-    <mc:Choice xmlns:p14="http://schemas.microsoft.com/office/powerpoint/2010/main" Requires="p14">
-      <p:transition spd="slow" p14:dur="1500">
-        <p:split orient="vert"/>
-      </p:transition>
-    </mc:Choice>
-    <mc:Fallback>
-      <p:transition spd="slow">
-        <p:split orient="vert"/>
-      </p:transition>
-    </mc:Fallback>
-  </mc:AlternateContent>
+  <p:transition spd="slow">
+    <p:wipe/>
+  </p:transition>
 </p:sld>
 </file>
 
@@ -5422,8 +5404,8 @@
           <a:noFill/>
         </p:spPr>
         <p:txBody>
-          <a:bodyPr wrap="none">
-            <a:spAutoFit/>
+          <a:bodyPr wrap="square" anchor="ctr">
+            <a:normAutofit/>
           </a:bodyPr>
           <a:lstStyle/>
           <a:p>
@@ -7526,9 +7508,18 @@
   <p:clrMapOvr>
     <a:masterClrMapping/>
   </p:clrMapOvr>
-  <p:transition spd="slow">
-    <p:wipe/>
-  </p:transition>
+  <mc:AlternateContent xmlns:mc="http://schemas.openxmlformats.org/markup-compatibility/2006">
+    <mc:Choice xmlns:p14="http://schemas.microsoft.com/office/powerpoint/2010/main" Requires="p14">
+      <p:transition spd="slow" p14:dur="1500">
+        <p:split orient="vert"/>
+      </p:transition>
+    </mc:Choice>
+    <mc:Fallback>
+      <p:transition spd="slow">
+        <p:split orient="vert"/>
+      </p:transition>
+    </mc:Fallback>
+  </mc:AlternateContent>
 </p:sld>
 </file>
 
@@ -7834,8 +7825,8 @@
           <a:noFill/>
         </p:spPr>
         <p:txBody>
-          <a:bodyPr wrap="none">
-            <a:spAutoFit/>
+          <a:bodyPr wrap="square">
+            <a:normAutofit/>
           </a:bodyPr>
           <a:lstStyle/>
           <a:p>
@@ -7990,8 +7981,8 @@
           <a:noFill/>
         </p:spPr>
         <p:txBody>
-          <a:bodyPr wrap="none">
-            <a:spAutoFit/>
+          <a:bodyPr wrap="square">
+            <a:normAutofit/>
           </a:bodyPr>
           <a:lstStyle/>
           <a:p>
@@ -8146,8 +8137,8 @@
           <a:noFill/>
         </p:spPr>
         <p:txBody>
-          <a:bodyPr wrap="none">
-            <a:spAutoFit/>
+          <a:bodyPr wrap="square">
+            <a:normAutofit/>
           </a:bodyPr>
           <a:lstStyle/>
           <a:p>
@@ -8302,8 +8293,8 @@
           <a:noFill/>
         </p:spPr>
         <p:txBody>
-          <a:bodyPr wrap="none">
-            <a:spAutoFit/>
+          <a:bodyPr wrap="square">
+            <a:normAutofit/>
           </a:bodyPr>
           <a:lstStyle/>
           <a:p>
@@ -8436,6 +8427,9 @@
   <p:clrMapOvr>
     <a:masterClrMapping/>
   </p:clrMapOvr>
+  <p:transition spd="slow">
+    <p:wipe/>
+  </p:transition>
 </p:sld>
 </file>
 
@@ -14513,8 +14507,8 @@
           <a:noFill/>
         </p:spPr>
         <p:txBody>
-          <a:bodyPr wrap="none">
-            <a:spAutoFit/>
+          <a:bodyPr wrap="square">
+            <a:normAutofit/>
           </a:bodyPr>
           <a:lstStyle/>
           <a:p>
@@ -14539,16 +14533,16 @@
         <p:spPr>
           <a:xfrm>
             <a:off x="9601200" y="228600"/>
-            <a:ext cx="2286000" cy="320040"/>
-          </a:xfrm>
-          <a:prstGeom prst="rect">
-            <a:avLst/>
-          </a:prstGeom>
-          <a:noFill/>
-        </p:spPr>
-        <p:txBody>
-          <a:bodyPr wrap="none">
-            <a:spAutoFit/>
+            <a:ext cx="1577340" cy="320040"/>
+          </a:xfrm>
+          <a:prstGeom prst="rect">
+            <a:avLst/>
+          </a:prstGeom>
+          <a:noFill/>
+        </p:spPr>
+        <p:txBody>
+          <a:bodyPr wrap="square">
+            <a:normAutofit/>
           </a:bodyPr>
           <a:lstStyle/>
           <a:p>
@@ -14597,7 +14591,7 @@
         <p:spPr>
           <a:xfrm>
             <a:off x="7543800" y="914400"/>
-            <a:ext cx="2286000" cy="347472"/>
+            <a:ext cx="1577340" cy="347472"/>
           </a:xfrm>
           <a:prstGeom prst="rect">
             <a:avLst/>
@@ -14649,8 +14643,8 @@
           <a:noFill/>
         </p:spPr>
         <p:txBody>
-          <a:bodyPr wrap="none">
-            <a:spAutoFit/>
+          <a:bodyPr wrap="square">
+            <a:normAutofit/>
           </a:bodyPr>
           <a:lstStyle/>
           <a:p>
@@ -14674,8 +14668,8 @@
         </p:nvSpPr>
         <p:spPr>
           <a:xfrm>
-            <a:off x="9829800" y="914400"/>
-            <a:ext cx="1463040" cy="347472"/>
+            <a:off x="9121140" y="914400"/>
+            <a:ext cx="1009498" cy="347472"/>
           </a:xfrm>
           <a:prstGeom prst="rect">
             <a:avLst/>
@@ -14718,17 +14712,17 @@
         </p:nvSpPr>
         <p:spPr>
           <a:xfrm>
-            <a:off x="9875520" y="941832"/>
-            <a:ext cx="1371600" cy="292608"/>
-          </a:xfrm>
-          <a:prstGeom prst="rect">
-            <a:avLst/>
-          </a:prstGeom>
-          <a:noFill/>
-        </p:spPr>
-        <p:txBody>
-          <a:bodyPr wrap="none">
-            <a:spAutoFit/>
+            <a:off x="9166860" y="941832"/>
+            <a:ext cx="963778" cy="292608"/>
+          </a:xfrm>
+          <a:prstGeom prst="rect">
+            <a:avLst/>
+          </a:prstGeom>
+          <a:noFill/>
+        </p:spPr>
+        <p:txBody>
+          <a:bodyPr wrap="square">
+            <a:normAutofit/>
           </a:bodyPr>
           <a:lstStyle/>
           <a:p>
@@ -14752,8 +14746,8 @@
         </p:nvSpPr>
         <p:spPr>
           <a:xfrm>
-            <a:off x="11292840" y="914400"/>
-            <a:ext cx="1463040" cy="347472"/>
+            <a:off x="10130638" y="914400"/>
+            <a:ext cx="1009498" cy="347472"/>
           </a:xfrm>
           <a:prstGeom prst="rect">
             <a:avLst/>
@@ -14796,17 +14790,17 @@
         </p:nvSpPr>
         <p:spPr>
           <a:xfrm>
-            <a:off x="11338560" y="941832"/>
-            <a:ext cx="1371600" cy="292608"/>
-          </a:xfrm>
-          <a:prstGeom prst="rect">
-            <a:avLst/>
-          </a:prstGeom>
-          <a:noFill/>
-        </p:spPr>
-        <p:txBody>
-          <a:bodyPr wrap="none">
-            <a:spAutoFit/>
+            <a:off x="10176358" y="941832"/>
+            <a:ext cx="963778" cy="292608"/>
+          </a:xfrm>
+          <a:prstGeom prst="rect">
+            <a:avLst/>
+          </a:prstGeom>
+          <a:noFill/>
+        </p:spPr>
+        <p:txBody>
+          <a:bodyPr wrap="square">
+            <a:normAutofit/>
           </a:bodyPr>
           <a:lstStyle/>
           <a:p>
@@ -14830,8 +14824,8 @@
         </p:nvSpPr>
         <p:spPr>
           <a:xfrm>
-            <a:off x="12755880" y="914400"/>
-            <a:ext cx="1188720" cy="347472"/>
+            <a:off x="11140136" y="914400"/>
+            <a:ext cx="820217" cy="347472"/>
           </a:xfrm>
           <a:prstGeom prst="rect">
             <a:avLst/>
@@ -14874,17 +14868,17 @@
         </p:nvSpPr>
         <p:spPr>
           <a:xfrm>
-            <a:off x="12801600" y="941832"/>
-            <a:ext cx="1097280" cy="292608"/>
-          </a:xfrm>
-          <a:prstGeom prst="rect">
-            <a:avLst/>
-          </a:prstGeom>
-          <a:noFill/>
-        </p:spPr>
-        <p:txBody>
-          <a:bodyPr wrap="none">
-            <a:spAutoFit/>
+            <a:off x="11185856" y="941832"/>
+            <a:ext cx="774497" cy="292608"/>
+          </a:xfrm>
+          <a:prstGeom prst="rect">
+            <a:avLst/>
+          </a:prstGeom>
+          <a:noFill/>
+        </p:spPr>
+        <p:txBody>
+          <a:bodyPr wrap="square">
+            <a:normAutofit/>
           </a:bodyPr>
           <a:lstStyle/>
           <a:p>
@@ -14909,7 +14903,7 @@
         <p:spPr>
           <a:xfrm>
             <a:off x="7543800" y="1261872"/>
-            <a:ext cx="2286000" cy="457200"/>
+            <a:ext cx="1577340" cy="457200"/>
           </a:xfrm>
           <a:prstGeom prst="rect">
             <a:avLst/>
@@ -14961,8 +14955,8 @@
           <a:noFill/>
         </p:spPr>
         <p:txBody>
-          <a:bodyPr wrap="none">
-            <a:spAutoFit/>
+          <a:bodyPr wrap="square">
+            <a:normAutofit/>
           </a:bodyPr>
           <a:lstStyle/>
           <a:p>
@@ -14986,8 +14980,8 @@
         </p:nvSpPr>
         <p:spPr>
           <a:xfrm>
-            <a:off x="9829800" y="1261872"/>
-            <a:ext cx="1463040" cy="457200"/>
+            <a:off x="9121140" y="1261872"/>
+            <a:ext cx="1009498" cy="457200"/>
           </a:xfrm>
           <a:prstGeom prst="rect">
             <a:avLst/>
@@ -15030,17 +15024,17 @@
         </p:nvSpPr>
         <p:spPr>
           <a:xfrm>
-            <a:off x="9875520" y="1298448"/>
-            <a:ext cx="1371600" cy="365760"/>
-          </a:xfrm>
-          <a:prstGeom prst="rect">
-            <a:avLst/>
-          </a:prstGeom>
-          <a:noFill/>
-        </p:spPr>
-        <p:txBody>
-          <a:bodyPr wrap="none">
-            <a:spAutoFit/>
+            <a:off x="9166860" y="1298448"/>
+            <a:ext cx="963778" cy="365760"/>
+          </a:xfrm>
+          <a:prstGeom prst="rect">
+            <a:avLst/>
+          </a:prstGeom>
+          <a:noFill/>
+        </p:spPr>
+        <p:txBody>
+          <a:bodyPr wrap="square">
+            <a:normAutofit/>
           </a:bodyPr>
           <a:lstStyle/>
           <a:p>
@@ -15064,8 +15058,8 @@
         </p:nvSpPr>
         <p:spPr>
           <a:xfrm>
-            <a:off x="11292840" y="1261872"/>
-            <a:ext cx="1463040" cy="457200"/>
+            <a:off x="10130638" y="1261872"/>
+            <a:ext cx="1009498" cy="457200"/>
           </a:xfrm>
           <a:prstGeom prst="rect">
             <a:avLst/>
@@ -15108,17 +15102,17 @@
         </p:nvSpPr>
         <p:spPr>
           <a:xfrm>
-            <a:off x="11338560" y="1298448"/>
-            <a:ext cx="1371600" cy="365760"/>
-          </a:xfrm>
-          <a:prstGeom prst="rect">
-            <a:avLst/>
-          </a:prstGeom>
-          <a:noFill/>
-        </p:spPr>
-        <p:txBody>
-          <a:bodyPr wrap="none">
-            <a:spAutoFit/>
+            <a:off x="10176358" y="1298448"/>
+            <a:ext cx="963778" cy="365760"/>
+          </a:xfrm>
+          <a:prstGeom prst="rect">
+            <a:avLst/>
+          </a:prstGeom>
+          <a:noFill/>
+        </p:spPr>
+        <p:txBody>
+          <a:bodyPr wrap="square">
+            <a:normAutofit/>
           </a:bodyPr>
           <a:lstStyle/>
           <a:p>
@@ -15142,8 +15136,8 @@
         </p:nvSpPr>
         <p:spPr>
           <a:xfrm>
-            <a:off x="12755880" y="1261872"/>
-            <a:ext cx="1188720" cy="457200"/>
+            <a:off x="11140136" y="1261872"/>
+            <a:ext cx="820217" cy="457200"/>
           </a:xfrm>
           <a:prstGeom prst="rect">
             <a:avLst/>
@@ -15186,17 +15180,17 @@
         </p:nvSpPr>
         <p:spPr>
           <a:xfrm>
-            <a:off x="12801600" y="1298448"/>
-            <a:ext cx="1097280" cy="365760"/>
-          </a:xfrm>
-          <a:prstGeom prst="rect">
-            <a:avLst/>
-          </a:prstGeom>
-          <a:noFill/>
-        </p:spPr>
-        <p:txBody>
-          <a:bodyPr wrap="none">
-            <a:spAutoFit/>
+            <a:off x="11185856" y="1298448"/>
+            <a:ext cx="774497" cy="365760"/>
+          </a:xfrm>
+          <a:prstGeom prst="rect">
+            <a:avLst/>
+          </a:prstGeom>
+          <a:noFill/>
+        </p:spPr>
+        <p:txBody>
+          <a:bodyPr wrap="square">
+            <a:normAutofit/>
           </a:bodyPr>
           <a:lstStyle/>
           <a:p>
@@ -15221,7 +15215,7 @@
         <p:spPr>
           <a:xfrm>
             <a:off x="7543800" y="1737360"/>
-            <a:ext cx="2286000" cy="457200"/>
+            <a:ext cx="1577340" cy="457200"/>
           </a:xfrm>
           <a:prstGeom prst="rect">
             <a:avLst/>
@@ -15273,8 +15267,8 @@
           <a:noFill/>
         </p:spPr>
         <p:txBody>
-          <a:bodyPr wrap="none">
-            <a:spAutoFit/>
+          <a:bodyPr wrap="square">
+            <a:normAutofit/>
           </a:bodyPr>
           <a:lstStyle/>
           <a:p>
@@ -15298,8 +15292,8 @@
         </p:nvSpPr>
         <p:spPr>
           <a:xfrm>
-            <a:off x="9829800" y="1737360"/>
-            <a:ext cx="1463040" cy="457200"/>
+            <a:off x="9121140" y="1737360"/>
+            <a:ext cx="1009498" cy="457200"/>
           </a:xfrm>
           <a:prstGeom prst="rect">
             <a:avLst/>
@@ -15342,17 +15336,17 @@
         </p:nvSpPr>
         <p:spPr>
           <a:xfrm>
-            <a:off x="9875520" y="1773936"/>
-            <a:ext cx="1371600" cy="365760"/>
-          </a:xfrm>
-          <a:prstGeom prst="rect">
-            <a:avLst/>
-          </a:prstGeom>
-          <a:noFill/>
-        </p:spPr>
-        <p:txBody>
-          <a:bodyPr wrap="none">
-            <a:spAutoFit/>
+            <a:off x="9166860" y="1773936"/>
+            <a:ext cx="963778" cy="365760"/>
+          </a:xfrm>
+          <a:prstGeom prst="rect">
+            <a:avLst/>
+          </a:prstGeom>
+          <a:noFill/>
+        </p:spPr>
+        <p:txBody>
+          <a:bodyPr wrap="square">
+            <a:normAutofit/>
           </a:bodyPr>
           <a:lstStyle/>
           <a:p>
@@ -15376,8 +15370,8 @@
         </p:nvSpPr>
         <p:spPr>
           <a:xfrm>
-            <a:off x="11292840" y="1737360"/>
-            <a:ext cx="1463040" cy="457200"/>
+            <a:off x="10130638" y="1737360"/>
+            <a:ext cx="1009498" cy="457200"/>
           </a:xfrm>
           <a:prstGeom prst="rect">
             <a:avLst/>
@@ -15420,17 +15414,17 @@
         </p:nvSpPr>
         <p:spPr>
           <a:xfrm>
-            <a:off x="11338560" y="1773936"/>
-            <a:ext cx="1371600" cy="365760"/>
-          </a:xfrm>
-          <a:prstGeom prst="rect">
-            <a:avLst/>
-          </a:prstGeom>
-          <a:noFill/>
-        </p:spPr>
-        <p:txBody>
-          <a:bodyPr wrap="none">
-            <a:spAutoFit/>
+            <a:off x="10176358" y="1773936"/>
+            <a:ext cx="963778" cy="365760"/>
+          </a:xfrm>
+          <a:prstGeom prst="rect">
+            <a:avLst/>
+          </a:prstGeom>
+          <a:noFill/>
+        </p:spPr>
+        <p:txBody>
+          <a:bodyPr wrap="square">
+            <a:normAutofit/>
           </a:bodyPr>
           <a:lstStyle/>
           <a:p>
@@ -15454,8 +15448,8 @@
         </p:nvSpPr>
         <p:spPr>
           <a:xfrm>
-            <a:off x="12755880" y="1737360"/>
-            <a:ext cx="1188720" cy="457200"/>
+            <a:off x="11140136" y="1737360"/>
+            <a:ext cx="820217" cy="457200"/>
           </a:xfrm>
           <a:prstGeom prst="rect">
             <a:avLst/>
@@ -15498,17 +15492,17 @@
         </p:nvSpPr>
         <p:spPr>
           <a:xfrm>
-            <a:off x="12801600" y="1773936"/>
-            <a:ext cx="1097280" cy="365760"/>
-          </a:xfrm>
-          <a:prstGeom prst="rect">
-            <a:avLst/>
-          </a:prstGeom>
-          <a:noFill/>
-        </p:spPr>
-        <p:txBody>
-          <a:bodyPr wrap="none">
-            <a:spAutoFit/>
+            <a:off x="11185856" y="1773936"/>
+            <a:ext cx="774497" cy="365760"/>
+          </a:xfrm>
+          <a:prstGeom prst="rect">
+            <a:avLst/>
+          </a:prstGeom>
+          <a:noFill/>
+        </p:spPr>
+        <p:txBody>
+          <a:bodyPr wrap="square">
+            <a:normAutofit/>
           </a:bodyPr>
           <a:lstStyle/>
           <a:p>
@@ -15533,7 +15527,7 @@
         <p:spPr>
           <a:xfrm>
             <a:off x="7543800" y="2212848"/>
-            <a:ext cx="2286000" cy="457200"/>
+            <a:ext cx="1577340" cy="457200"/>
           </a:xfrm>
           <a:prstGeom prst="rect">
             <a:avLst/>
@@ -15585,8 +15579,8 @@
           <a:noFill/>
         </p:spPr>
         <p:txBody>
-          <a:bodyPr wrap="none">
-            <a:spAutoFit/>
+          <a:bodyPr wrap="square">
+            <a:normAutofit/>
           </a:bodyPr>
           <a:lstStyle/>
           <a:p>
@@ -15610,8 +15604,8 @@
         </p:nvSpPr>
         <p:spPr>
           <a:xfrm>
-            <a:off x="9829800" y="2212848"/>
-            <a:ext cx="1463040" cy="457200"/>
+            <a:off x="9121140" y="2212848"/>
+            <a:ext cx="1009498" cy="457200"/>
           </a:xfrm>
           <a:prstGeom prst="rect">
             <a:avLst/>
@@ -15654,17 +15648,17 @@
         </p:nvSpPr>
         <p:spPr>
           <a:xfrm>
-            <a:off x="9875520" y="2249424"/>
-            <a:ext cx="1371600" cy="365760"/>
-          </a:xfrm>
-          <a:prstGeom prst="rect">
-            <a:avLst/>
-          </a:prstGeom>
-          <a:noFill/>
-        </p:spPr>
-        <p:txBody>
-          <a:bodyPr wrap="none">
-            <a:spAutoFit/>
+            <a:off x="9166860" y="2249424"/>
+            <a:ext cx="963778" cy="365760"/>
+          </a:xfrm>
+          <a:prstGeom prst="rect">
+            <a:avLst/>
+          </a:prstGeom>
+          <a:noFill/>
+        </p:spPr>
+        <p:txBody>
+          <a:bodyPr wrap="square">
+            <a:normAutofit/>
           </a:bodyPr>
           <a:lstStyle/>
           <a:p>
@@ -15688,8 +15682,8 @@
         </p:nvSpPr>
         <p:spPr>
           <a:xfrm>
-            <a:off x="11292840" y="2212848"/>
-            <a:ext cx="1463040" cy="457200"/>
+            <a:off x="10130638" y="2212848"/>
+            <a:ext cx="1009498" cy="457200"/>
           </a:xfrm>
           <a:prstGeom prst="rect">
             <a:avLst/>
@@ -15732,17 +15726,17 @@
         </p:nvSpPr>
         <p:spPr>
           <a:xfrm>
-            <a:off x="11338560" y="2249424"/>
-            <a:ext cx="1371600" cy="365760"/>
-          </a:xfrm>
-          <a:prstGeom prst="rect">
-            <a:avLst/>
-          </a:prstGeom>
-          <a:noFill/>
-        </p:spPr>
-        <p:txBody>
-          <a:bodyPr wrap="none">
-            <a:spAutoFit/>
+            <a:off x="10176358" y="2249424"/>
+            <a:ext cx="963778" cy="365760"/>
+          </a:xfrm>
+          <a:prstGeom prst="rect">
+            <a:avLst/>
+          </a:prstGeom>
+          <a:noFill/>
+        </p:spPr>
+        <p:txBody>
+          <a:bodyPr wrap="square">
+            <a:normAutofit/>
           </a:bodyPr>
           <a:lstStyle/>
           <a:p>
@@ -15766,8 +15760,8 @@
         </p:nvSpPr>
         <p:spPr>
           <a:xfrm>
-            <a:off x="12755880" y="2212848"/>
-            <a:ext cx="1188720" cy="457200"/>
+            <a:off x="11140136" y="2212848"/>
+            <a:ext cx="820217" cy="457200"/>
           </a:xfrm>
           <a:prstGeom prst="rect">
             <a:avLst/>
@@ -15810,17 +15804,17 @@
         </p:nvSpPr>
         <p:spPr>
           <a:xfrm>
-            <a:off x="12801600" y="2249424"/>
-            <a:ext cx="1097280" cy="365760"/>
-          </a:xfrm>
-          <a:prstGeom prst="rect">
-            <a:avLst/>
-          </a:prstGeom>
-          <a:noFill/>
-        </p:spPr>
-        <p:txBody>
-          <a:bodyPr wrap="none">
-            <a:spAutoFit/>
+            <a:off x="11185856" y="2249424"/>
+            <a:ext cx="774497" cy="365760"/>
+          </a:xfrm>
+          <a:prstGeom prst="rect">
+            <a:avLst/>
+          </a:prstGeom>
+          <a:noFill/>
+        </p:spPr>
+        <p:txBody>
+          <a:bodyPr wrap="square">
+            <a:normAutofit/>
           </a:bodyPr>
           <a:lstStyle/>
           <a:p>
@@ -15845,7 +15839,7 @@
         <p:spPr>
           <a:xfrm>
             <a:off x="7543800" y="2688336"/>
-            <a:ext cx="2286000" cy="457200"/>
+            <a:ext cx="1577340" cy="457200"/>
           </a:xfrm>
           <a:prstGeom prst="rect">
             <a:avLst/>
@@ -15897,8 +15891,8 @@
           <a:noFill/>
         </p:spPr>
         <p:txBody>
-          <a:bodyPr wrap="none">
-            <a:spAutoFit/>
+          <a:bodyPr wrap="square">
+            <a:normAutofit/>
           </a:bodyPr>
           <a:lstStyle/>
           <a:p>
@@ -15922,8 +15916,8 @@
         </p:nvSpPr>
         <p:spPr>
           <a:xfrm>
-            <a:off x="9829800" y="2688336"/>
-            <a:ext cx="1463040" cy="457200"/>
+            <a:off x="9121140" y="2688336"/>
+            <a:ext cx="1009498" cy="457200"/>
           </a:xfrm>
           <a:prstGeom prst="rect">
             <a:avLst/>
@@ -15966,17 +15960,17 @@
         </p:nvSpPr>
         <p:spPr>
           <a:xfrm>
-            <a:off x="9875520" y="2724912"/>
-            <a:ext cx="1371600" cy="365760"/>
-          </a:xfrm>
-          <a:prstGeom prst="rect">
-            <a:avLst/>
-          </a:prstGeom>
-          <a:noFill/>
-        </p:spPr>
-        <p:txBody>
-          <a:bodyPr wrap="none">
-            <a:spAutoFit/>
+            <a:off x="9166860" y="2724912"/>
+            <a:ext cx="963778" cy="365760"/>
+          </a:xfrm>
+          <a:prstGeom prst="rect">
+            <a:avLst/>
+          </a:prstGeom>
+          <a:noFill/>
+        </p:spPr>
+        <p:txBody>
+          <a:bodyPr wrap="square">
+            <a:normAutofit/>
           </a:bodyPr>
           <a:lstStyle/>
           <a:p>
@@ -16000,8 +15994,8 @@
         </p:nvSpPr>
         <p:spPr>
           <a:xfrm>
-            <a:off x="11292840" y="2688336"/>
-            <a:ext cx="1463040" cy="457200"/>
+            <a:off x="10130638" y="2688336"/>
+            <a:ext cx="1009498" cy="457200"/>
           </a:xfrm>
           <a:prstGeom prst="rect">
             <a:avLst/>
@@ -16044,17 +16038,17 @@
         </p:nvSpPr>
         <p:spPr>
           <a:xfrm>
-            <a:off x="11338560" y="2724912"/>
-            <a:ext cx="1371600" cy="365760"/>
-          </a:xfrm>
-          <a:prstGeom prst="rect">
-            <a:avLst/>
-          </a:prstGeom>
-          <a:noFill/>
-        </p:spPr>
-        <p:txBody>
-          <a:bodyPr wrap="none">
-            <a:spAutoFit/>
+            <a:off x="10176358" y="2724912"/>
+            <a:ext cx="963778" cy="365760"/>
+          </a:xfrm>
+          <a:prstGeom prst="rect">
+            <a:avLst/>
+          </a:prstGeom>
+          <a:noFill/>
+        </p:spPr>
+        <p:txBody>
+          <a:bodyPr wrap="square">
+            <a:normAutofit/>
           </a:bodyPr>
           <a:lstStyle/>
           <a:p>
@@ -16078,8 +16072,8 @@
         </p:nvSpPr>
         <p:spPr>
           <a:xfrm>
-            <a:off x="12755880" y="2688336"/>
-            <a:ext cx="1188720" cy="457200"/>
+            <a:off x="11140136" y="2688336"/>
+            <a:ext cx="820217" cy="457200"/>
           </a:xfrm>
           <a:prstGeom prst="rect">
             <a:avLst/>
@@ -16122,17 +16116,17 @@
         </p:nvSpPr>
         <p:spPr>
           <a:xfrm>
-            <a:off x="12801600" y="2724912"/>
-            <a:ext cx="1097280" cy="365760"/>
-          </a:xfrm>
-          <a:prstGeom prst="rect">
-            <a:avLst/>
-          </a:prstGeom>
-          <a:noFill/>
-        </p:spPr>
-        <p:txBody>
-          <a:bodyPr wrap="none">
-            <a:spAutoFit/>
+            <a:off x="11185856" y="2724912"/>
+            <a:ext cx="774497" cy="365760"/>
+          </a:xfrm>
+          <a:prstGeom prst="rect">
+            <a:avLst/>
+          </a:prstGeom>
+          <a:noFill/>
+        </p:spPr>
+        <p:txBody>
+          <a:bodyPr wrap="square">
+            <a:normAutofit/>
           </a:bodyPr>
           <a:lstStyle/>
           <a:p>
@@ -16157,7 +16151,7 @@
         <p:spPr>
           <a:xfrm>
             <a:off x="7543800" y="3163824"/>
-            <a:ext cx="2286000" cy="457200"/>
+            <a:ext cx="1577340" cy="457200"/>
           </a:xfrm>
           <a:prstGeom prst="rect">
             <a:avLst/>
@@ -16209,8 +16203,8 @@
           <a:noFill/>
         </p:spPr>
         <p:txBody>
-          <a:bodyPr wrap="none">
-            <a:spAutoFit/>
+          <a:bodyPr wrap="square">
+            <a:normAutofit/>
           </a:bodyPr>
           <a:lstStyle/>
           <a:p>
@@ -16234,8 +16228,8 @@
         </p:nvSpPr>
         <p:spPr>
           <a:xfrm>
-            <a:off x="9829800" y="3163824"/>
-            <a:ext cx="1463040" cy="457200"/>
+            <a:off x="9121140" y="3163824"/>
+            <a:ext cx="1009498" cy="457200"/>
           </a:xfrm>
           <a:prstGeom prst="rect">
             <a:avLst/>
@@ -16278,17 +16272,17 @@
         </p:nvSpPr>
         <p:spPr>
           <a:xfrm>
-            <a:off x="9875520" y="3200400"/>
-            <a:ext cx="1371600" cy="365760"/>
-          </a:xfrm>
-          <a:prstGeom prst="rect">
-            <a:avLst/>
-          </a:prstGeom>
-          <a:noFill/>
-        </p:spPr>
-        <p:txBody>
-          <a:bodyPr wrap="none">
-            <a:spAutoFit/>
+            <a:off x="9166860" y="3200400"/>
+            <a:ext cx="963778" cy="365760"/>
+          </a:xfrm>
+          <a:prstGeom prst="rect">
+            <a:avLst/>
+          </a:prstGeom>
+          <a:noFill/>
+        </p:spPr>
+        <p:txBody>
+          <a:bodyPr wrap="square">
+            <a:normAutofit/>
           </a:bodyPr>
           <a:lstStyle/>
           <a:p>
@@ -16312,8 +16306,8 @@
         </p:nvSpPr>
         <p:spPr>
           <a:xfrm>
-            <a:off x="11292840" y="3163824"/>
-            <a:ext cx="1463040" cy="457200"/>
+            <a:off x="10130638" y="3163824"/>
+            <a:ext cx="1009498" cy="457200"/>
           </a:xfrm>
           <a:prstGeom prst="rect">
             <a:avLst/>
@@ -16356,17 +16350,17 @@
         </p:nvSpPr>
         <p:spPr>
           <a:xfrm>
-            <a:off x="11338560" y="3200400"/>
-            <a:ext cx="1371600" cy="365760"/>
-          </a:xfrm>
-          <a:prstGeom prst="rect">
-            <a:avLst/>
-          </a:prstGeom>
-          <a:noFill/>
-        </p:spPr>
-        <p:txBody>
-          <a:bodyPr wrap="none">
-            <a:spAutoFit/>
+            <a:off x="10176358" y="3200400"/>
+            <a:ext cx="963778" cy="365760"/>
+          </a:xfrm>
+          <a:prstGeom prst="rect">
+            <a:avLst/>
+          </a:prstGeom>
+          <a:noFill/>
+        </p:spPr>
+        <p:txBody>
+          <a:bodyPr wrap="square">
+            <a:normAutofit/>
           </a:bodyPr>
           <a:lstStyle/>
           <a:p>
@@ -16390,8 +16384,8 @@
         </p:nvSpPr>
         <p:spPr>
           <a:xfrm>
-            <a:off x="12755880" y="3163824"/>
-            <a:ext cx="1188720" cy="457200"/>
+            <a:off x="11140136" y="3163824"/>
+            <a:ext cx="820217" cy="457200"/>
           </a:xfrm>
           <a:prstGeom prst="rect">
             <a:avLst/>
@@ -16434,17 +16428,17 @@
         </p:nvSpPr>
         <p:spPr>
           <a:xfrm>
-            <a:off x="12801600" y="3200400"/>
-            <a:ext cx="1097280" cy="365760"/>
-          </a:xfrm>
-          <a:prstGeom prst="rect">
-            <a:avLst/>
-          </a:prstGeom>
-          <a:noFill/>
-        </p:spPr>
-        <p:txBody>
-          <a:bodyPr wrap="none">
-            <a:spAutoFit/>
+            <a:off x="11185856" y="3200400"/>
+            <a:ext cx="774497" cy="365760"/>
+          </a:xfrm>
+          <a:prstGeom prst="rect">
+            <a:avLst/>
+          </a:prstGeom>
+          <a:noFill/>
+        </p:spPr>
+        <p:txBody>
+          <a:bodyPr wrap="square">
+            <a:normAutofit/>
           </a:bodyPr>
           <a:lstStyle/>
           <a:p>
@@ -16469,7 +16463,7 @@
         <p:spPr>
           <a:xfrm>
             <a:off x="7543800" y="3639312"/>
-            <a:ext cx="2286000" cy="457200"/>
+            <a:ext cx="1577340" cy="457200"/>
           </a:xfrm>
           <a:prstGeom prst="rect">
             <a:avLst/>
@@ -16521,8 +16515,8 @@
           <a:noFill/>
         </p:spPr>
         <p:txBody>
-          <a:bodyPr wrap="none">
-            <a:spAutoFit/>
+          <a:bodyPr wrap="square">
+            <a:normAutofit/>
           </a:bodyPr>
           <a:lstStyle/>
           <a:p>
@@ -16546,8 +16540,8 @@
         </p:nvSpPr>
         <p:spPr>
           <a:xfrm>
-            <a:off x="9829800" y="3639312"/>
-            <a:ext cx="1463040" cy="457200"/>
+            <a:off x="9121140" y="3639312"/>
+            <a:ext cx="1009498" cy="457200"/>
           </a:xfrm>
           <a:prstGeom prst="rect">
             <a:avLst/>
@@ -16590,17 +16584,17 @@
         </p:nvSpPr>
         <p:spPr>
           <a:xfrm>
-            <a:off x="9875520" y="3675887"/>
-            <a:ext cx="1371600" cy="365760"/>
-          </a:xfrm>
-          <a:prstGeom prst="rect">
-            <a:avLst/>
-          </a:prstGeom>
-          <a:noFill/>
-        </p:spPr>
-        <p:txBody>
-          <a:bodyPr wrap="none">
-            <a:spAutoFit/>
+            <a:off x="9166860" y="3675887"/>
+            <a:ext cx="963778" cy="365760"/>
+          </a:xfrm>
+          <a:prstGeom prst="rect">
+            <a:avLst/>
+          </a:prstGeom>
+          <a:noFill/>
+        </p:spPr>
+        <p:txBody>
+          <a:bodyPr wrap="square">
+            <a:normAutofit/>
           </a:bodyPr>
           <a:lstStyle/>
           <a:p>
@@ -16624,8 +16618,8 @@
         </p:nvSpPr>
         <p:spPr>
           <a:xfrm>
-            <a:off x="11292840" y="3639312"/>
-            <a:ext cx="1463040" cy="457200"/>
+            <a:off x="10130638" y="3639312"/>
+            <a:ext cx="1009498" cy="457200"/>
           </a:xfrm>
           <a:prstGeom prst="rect">
             <a:avLst/>
@@ -16668,17 +16662,17 @@
         </p:nvSpPr>
         <p:spPr>
           <a:xfrm>
-            <a:off x="11338560" y="3675887"/>
-            <a:ext cx="1371600" cy="365760"/>
-          </a:xfrm>
-          <a:prstGeom prst="rect">
-            <a:avLst/>
-          </a:prstGeom>
-          <a:noFill/>
-        </p:spPr>
-        <p:txBody>
-          <a:bodyPr wrap="none">
-            <a:spAutoFit/>
+            <a:off x="10176358" y="3675887"/>
+            <a:ext cx="963778" cy="365760"/>
+          </a:xfrm>
+          <a:prstGeom prst="rect">
+            <a:avLst/>
+          </a:prstGeom>
+          <a:noFill/>
+        </p:spPr>
+        <p:txBody>
+          <a:bodyPr wrap="square">
+            <a:normAutofit/>
           </a:bodyPr>
           <a:lstStyle/>
           <a:p>
@@ -16702,8 +16696,8 @@
         </p:nvSpPr>
         <p:spPr>
           <a:xfrm>
-            <a:off x="12755880" y="3639312"/>
-            <a:ext cx="1188720" cy="457200"/>
+            <a:off x="11140136" y="3639312"/>
+            <a:ext cx="820217" cy="457200"/>
           </a:xfrm>
           <a:prstGeom prst="rect">
             <a:avLst/>
@@ -16746,17 +16740,17 @@
         </p:nvSpPr>
         <p:spPr>
           <a:xfrm>
-            <a:off x="12801600" y="3675887"/>
-            <a:ext cx="1097280" cy="365760"/>
-          </a:xfrm>
-          <a:prstGeom prst="rect">
-            <a:avLst/>
-          </a:prstGeom>
-          <a:noFill/>
-        </p:spPr>
-        <p:txBody>
-          <a:bodyPr wrap="none">
-            <a:spAutoFit/>
+            <a:off x="11185856" y="3675887"/>
+            <a:ext cx="774497" cy="365760"/>
+          </a:xfrm>
+          <a:prstGeom prst="rect">
+            <a:avLst/>
+          </a:prstGeom>
+          <a:noFill/>
+        </p:spPr>
+        <p:txBody>
+          <a:bodyPr wrap="square">
+            <a:normAutofit/>
           </a:bodyPr>
           <a:lstStyle/>
           <a:p>
@@ -16833,8 +16827,8 @@
           <a:noFill/>
         </p:spPr>
         <p:txBody>
-          <a:bodyPr wrap="none">
-            <a:spAutoFit/>
+          <a:bodyPr wrap="square">
+            <a:normAutofit/>
           </a:bodyPr>
           <a:lstStyle/>
           <a:p>
@@ -16858,17 +16852,17 @@
         </p:nvSpPr>
         <p:spPr>
           <a:xfrm>
-            <a:off x="8412480" y="4206240"/>
-            <a:ext cx="3566160" cy="457200"/>
-          </a:xfrm>
-          <a:prstGeom prst="rect">
-            <a:avLst/>
-          </a:prstGeom>
-          <a:noFill/>
-        </p:spPr>
-        <p:txBody>
-          <a:bodyPr wrap="none">
-            <a:spAutoFit/>
+            <a:off x="8366760" y="4206240"/>
+            <a:ext cx="3547872" cy="457200"/>
+          </a:xfrm>
+          <a:prstGeom prst="rect">
+            <a:avLst/>
+          </a:prstGeom>
+          <a:noFill/>
+        </p:spPr>
+        <p:txBody>
+          <a:bodyPr wrap="square">
+            <a:normAutofit/>
           </a:bodyPr>
           <a:lstStyle/>
           <a:p>
@@ -16945,8 +16939,8 @@
           <a:noFill/>
         </p:spPr>
         <p:txBody>
-          <a:bodyPr wrap="none">
-            <a:spAutoFit/>
+          <a:bodyPr wrap="square">
+            <a:normAutofit/>
           </a:bodyPr>
           <a:lstStyle/>
           <a:p>
@@ -16970,17 +16964,17 @@
         </p:nvSpPr>
         <p:spPr>
           <a:xfrm>
-            <a:off x="8412480" y="4782312"/>
-            <a:ext cx="3566160" cy="457200"/>
-          </a:xfrm>
-          <a:prstGeom prst="rect">
-            <a:avLst/>
-          </a:prstGeom>
-          <a:noFill/>
-        </p:spPr>
-        <p:txBody>
-          <a:bodyPr wrap="none">
-            <a:spAutoFit/>
+            <a:off x="8366760" y="4782312"/>
+            <a:ext cx="3547872" cy="457200"/>
+          </a:xfrm>
+          <a:prstGeom prst="rect">
+            <a:avLst/>
+          </a:prstGeom>
+          <a:noFill/>
+        </p:spPr>
+        <p:txBody>
+          <a:bodyPr wrap="square">
+            <a:normAutofit/>
           </a:bodyPr>
           <a:lstStyle/>
           <a:p>
@@ -17057,8 +17051,8 @@
           <a:noFill/>
         </p:spPr>
         <p:txBody>
-          <a:bodyPr wrap="none">
-            <a:spAutoFit/>
+          <a:bodyPr wrap="square">
+            <a:normAutofit/>
           </a:bodyPr>
           <a:lstStyle/>
           <a:p>
@@ -17082,17 +17076,17 @@
         </p:nvSpPr>
         <p:spPr>
           <a:xfrm>
-            <a:off x="8412480" y="5358383"/>
-            <a:ext cx="3566160" cy="457200"/>
-          </a:xfrm>
-          <a:prstGeom prst="rect">
-            <a:avLst/>
-          </a:prstGeom>
-          <a:noFill/>
-        </p:spPr>
-        <p:txBody>
-          <a:bodyPr wrap="none">
-            <a:spAutoFit/>
+            <a:off x="8366760" y="5358383"/>
+            <a:ext cx="3547872" cy="457200"/>
+          </a:xfrm>
+          <a:prstGeom prst="rect">
+            <a:avLst/>
+          </a:prstGeom>
+          <a:noFill/>
+        </p:spPr>
+        <p:txBody>
+          <a:bodyPr wrap="square">
+            <a:normAutofit/>
           </a:bodyPr>
           <a:lstStyle/>
           <a:p>
@@ -17169,8 +17163,8 @@
           <a:noFill/>
         </p:spPr>
         <p:txBody>
-          <a:bodyPr wrap="none">
-            <a:spAutoFit/>
+          <a:bodyPr wrap="square">
+            <a:normAutofit/>
           </a:bodyPr>
           <a:lstStyle/>
           <a:p>
@@ -17247,8 +17241,8 @@
           <a:noFill/>
         </p:spPr>
         <p:txBody>
-          <a:bodyPr wrap="none">
-            <a:spAutoFit/>
+          <a:bodyPr wrap="square">
+            <a:normAutofit/>
           </a:bodyPr>
           <a:lstStyle/>
           <a:p>
@@ -17281,8 +17275,8 @@
           <a:noFill/>
         </p:spPr>
         <p:txBody>
-          <a:bodyPr wrap="none">
-            <a:spAutoFit/>
+          <a:bodyPr wrap="square">
+            <a:normAutofit/>
           </a:bodyPr>
           <a:lstStyle/>
           <a:p>
@@ -17303,6 +17297,9 @@
   <p:clrMapOvr>
     <a:masterClrMapping/>
   </p:clrMapOvr>
+  <p:transition spd="slow">
+    <p:wipe/>
+  </p:transition>
 </p:sld>
 </file>
 
@@ -19722,13 +19719,13 @@
   <p:clrMapOvr>
     <a:masterClrMapping/>
   </p:clrMapOvr>
-  <mc:AlternateContent xmlns:mc="http://schemas.openxmlformats.org/markup-compatibility/2006">
-    <mc:Choice xmlns:p159="http://schemas.microsoft.com/office/powerpoint/2015/09/main" Requires="p159">
+  <mc:AlternateContent xmlns:mc="http://schemas.openxmlformats.org/markup-compatibility/2006" xmlns:p159="http://schemas.microsoft.com/office/powerpoint/2015/09/main">
+    <mc:Choice Requires="p159">
       <p:transition xmlns:p14="http://schemas.microsoft.com/office/powerpoint/2010/main" spd="slow" p14:dur="2000">
         <p159:morph option="byObject"/>
       </p:transition>
     </mc:Choice>
-    <mc:Fallback>
+    <mc:Fallback xmlns="">
       <p:transition spd="slow">
         <p:fade/>
       </p:transition>

</xml_diff>